<commit_message>
Typo in slides; Nov 6 paper
</commit_message>
<xml_diff>
--- a/static/courses/cis-7000-fall2025/downloads/ESPH-shifting-advantages.pptx
+++ b/static/courses/cis-7000-fall2025/downloads/ESPH-shifting-advantages.pptx
@@ -2566,7 +2566,7 @@
           <a:p>
             <a:fld id="{8B03077B-A16D-7946-B45A-7953EEF17B81}" type="datetimeFigureOut">
               <a:rPr lang="en-US" smtClean="0"/>
-              <a:t>10/29/25</a:t>
+              <a:t>10/30/25</a:t>
             </a:fld>
             <a:endParaRPr lang="en-US"/>
           </a:p>
@@ -2887,6 +2887,31 @@
                 <a:ea typeface="+mn-ea"/>
                 <a:cs typeface="+mn-cs"/>
               </a:rPr>
+              <a:t>Click:</a:t>
+            </a:r>
+          </a:p>
+          <a:p>
+            <a:endParaRPr lang="en-US" sz="1200" b="0" i="0" kern="1200" dirty="0">
+              <a:solidFill>
+                <a:schemeClr val="tx1"/>
+              </a:solidFill>
+              <a:effectLst/>
+              <a:latin typeface="+mn-lt"/>
+              <a:ea typeface="+mn-ea"/>
+              <a:cs typeface="+mn-cs"/>
+            </a:endParaRPr>
+          </a:p>
+          <a:p>
+            <a:r>
+              <a:rPr lang="en-US" sz="1200" b="0" i="0" kern="1200" dirty="0">
+                <a:solidFill>
+                  <a:schemeClr val="tx1"/>
+                </a:solidFill>
+                <a:effectLst/>
+                <a:latin typeface="+mn-lt"/>
+                <a:ea typeface="+mn-ea"/>
+                <a:cs typeface="+mn-cs"/>
+              </a:rPr>
               <a:t>Before networking, defenders had the advantage: Lock the door and vet those with access and your computer would be “</a:t>
             </a:r>
             <a:r>
@@ -2988,6 +3013,31 @@
                 <a:cs typeface="+mn-cs"/>
               </a:rPr>
               <a:t>Other system-wide disadvantages compounded the problem, e.g., no real consequences for bad software</a:t>
+            </a:r>
+          </a:p>
+          <a:p>
+            <a:endParaRPr lang="en-US" sz="1200" b="0" i="0" kern="1200" dirty="0">
+              <a:solidFill>
+                <a:schemeClr val="tx1"/>
+              </a:solidFill>
+              <a:effectLst/>
+              <a:latin typeface="+mn-lt"/>
+              <a:ea typeface="+mn-ea"/>
+              <a:cs typeface="+mn-cs"/>
+            </a:endParaRPr>
+          </a:p>
+          <a:p>
+            <a:r>
+              <a:rPr lang="en-US" sz="1200" b="0" i="0" kern="1200" dirty="0">
+                <a:solidFill>
+                  <a:schemeClr val="tx1"/>
+                </a:solidFill>
+                <a:effectLst/>
+                <a:latin typeface="+mn-lt"/>
+                <a:ea typeface="+mn-ea"/>
+                <a:cs typeface="+mn-cs"/>
+              </a:rPr>
+              <a:t>---</a:t>
             </a:r>
           </a:p>
           <a:p>
@@ -4467,7 +4517,7 @@
           <a:p>
             <a:fld id="{6BC6361F-31DF-994C-9089-BE54C03D95A3}" type="datetimeFigureOut">
               <a:rPr lang="en-US" smtClean="0"/>
-              <a:t>10/29/25</a:t>
+              <a:t>10/30/25</a:t>
             </a:fld>
             <a:endParaRPr lang="en-US"/>
           </a:p>
@@ -4637,7 +4687,7 @@
           <a:p>
             <a:fld id="{6BC6361F-31DF-994C-9089-BE54C03D95A3}" type="datetimeFigureOut">
               <a:rPr lang="en-US" smtClean="0"/>
-              <a:t>10/29/25</a:t>
+              <a:t>10/30/25</a:t>
             </a:fld>
             <a:endParaRPr lang="en-US"/>
           </a:p>
@@ -4817,7 +4867,7 @@
           <a:p>
             <a:fld id="{6BC6361F-31DF-994C-9089-BE54C03D95A3}" type="datetimeFigureOut">
               <a:rPr lang="en-US" smtClean="0"/>
-              <a:t>10/29/25</a:t>
+              <a:t>10/30/25</a:t>
             </a:fld>
             <a:endParaRPr lang="en-US"/>
           </a:p>
@@ -4987,7 +5037,7 @@
           <a:p>
             <a:fld id="{6BC6361F-31DF-994C-9089-BE54C03D95A3}" type="datetimeFigureOut">
               <a:rPr lang="en-US" smtClean="0"/>
-              <a:t>10/29/25</a:t>
+              <a:t>10/30/25</a:t>
             </a:fld>
             <a:endParaRPr lang="en-US"/>
           </a:p>
@@ -5233,7 +5283,7 @@
           <a:p>
             <a:fld id="{6BC6361F-31DF-994C-9089-BE54C03D95A3}" type="datetimeFigureOut">
               <a:rPr lang="en-US" smtClean="0"/>
-              <a:t>10/29/25</a:t>
+              <a:t>10/30/25</a:t>
             </a:fld>
             <a:endParaRPr lang="en-US"/>
           </a:p>
@@ -5465,7 +5515,7 @@
           <a:p>
             <a:fld id="{6BC6361F-31DF-994C-9089-BE54C03D95A3}" type="datetimeFigureOut">
               <a:rPr lang="en-US" smtClean="0"/>
-              <a:t>10/29/25</a:t>
+              <a:t>10/30/25</a:t>
             </a:fld>
             <a:endParaRPr lang="en-US"/>
           </a:p>
@@ -5832,7 +5882,7 @@
           <a:p>
             <a:fld id="{6BC6361F-31DF-994C-9089-BE54C03D95A3}" type="datetimeFigureOut">
               <a:rPr lang="en-US" smtClean="0"/>
-              <a:t>10/29/25</a:t>
+              <a:t>10/30/25</a:t>
             </a:fld>
             <a:endParaRPr lang="en-US"/>
           </a:p>
@@ -5950,7 +6000,7 @@
           <a:p>
             <a:fld id="{6BC6361F-31DF-994C-9089-BE54C03D95A3}" type="datetimeFigureOut">
               <a:rPr lang="en-US" smtClean="0"/>
-              <a:t>10/29/25</a:t>
+              <a:t>10/30/25</a:t>
             </a:fld>
             <a:endParaRPr lang="en-US"/>
           </a:p>
@@ -6045,7 +6095,7 @@
           <a:p>
             <a:fld id="{6BC6361F-31DF-994C-9089-BE54C03D95A3}" type="datetimeFigureOut">
               <a:rPr lang="en-US" smtClean="0"/>
-              <a:t>10/29/25</a:t>
+              <a:t>10/30/25</a:t>
             </a:fld>
             <a:endParaRPr lang="en-US"/>
           </a:p>
@@ -6322,7 +6372,7 @@
           <a:p>
             <a:fld id="{6BC6361F-31DF-994C-9089-BE54C03D95A3}" type="datetimeFigureOut">
               <a:rPr lang="en-US" smtClean="0"/>
-              <a:t>10/29/25</a:t>
+              <a:t>10/30/25</a:t>
             </a:fld>
             <a:endParaRPr lang="en-US"/>
           </a:p>
@@ -6579,7 +6629,7 @@
           <a:p>
             <a:fld id="{6BC6361F-31DF-994C-9089-BE54C03D95A3}" type="datetimeFigureOut">
               <a:rPr lang="en-US" smtClean="0"/>
-              <a:t>10/29/25</a:t>
+              <a:t>10/30/25</a:t>
             </a:fld>
             <a:endParaRPr lang="en-US"/>
           </a:p>
@@ -6792,7 +6842,7 @@
           <a:p>
             <a:fld id="{6BC6361F-31DF-994C-9089-BE54C03D95A3}" type="datetimeFigureOut">
               <a:rPr lang="en-US" smtClean="0"/>
-              <a:t>10/29/25</a:t>
+              <a:t>10/30/25</a:t>
             </a:fld>
             <a:endParaRPr lang="en-US"/>
           </a:p>
@@ -7703,7 +7753,7 @@
           <a:p>
             <a:r>
               <a:rPr lang="en-US" dirty="0"/>
-              <a:t>Source: Veracode 2023 Annual Report on the State of Application Security</a:t>
+              <a:t>Source: Veracode 2025 Annual Report on the State of Application Security</a:t>
             </a:r>
           </a:p>
         </p:txBody>
@@ -10315,13 +10365,13 @@
   <p:clrMapOvr>
     <a:masterClrMapping/>
   </p:clrMapOvr>
-  <mc:AlternateContent xmlns:mc="http://schemas.openxmlformats.org/markup-compatibility/2006">
-    <mc:Choice xmlns:p159="http://schemas.microsoft.com/office/powerpoint/2015/09/main" Requires="p159">
+  <mc:AlternateContent xmlns:mc="http://schemas.openxmlformats.org/markup-compatibility/2006" xmlns:p159="http://schemas.microsoft.com/office/powerpoint/2015/09/main">
+    <mc:Choice Requires="p159">
       <p:transition xmlns:p14="http://schemas.microsoft.com/office/powerpoint/2010/main" spd="slow" p14:dur="2000">
         <p159:morph option="byObject"/>
       </p:transition>
     </mc:Choice>
-    <mc:Fallback>
+    <mc:Fallback xmlns="">
       <p:transition spd="slow">
         <p:fade/>
       </p:transition>
@@ -11239,13 +11289,13 @@
   <p:clrMapOvr>
     <a:masterClrMapping/>
   </p:clrMapOvr>
-  <mc:AlternateContent xmlns:mc="http://schemas.openxmlformats.org/markup-compatibility/2006">
-    <mc:Choice xmlns:p159="http://schemas.microsoft.com/office/powerpoint/2015/09/main" Requires="p159">
+  <mc:AlternateContent xmlns:mc="http://schemas.openxmlformats.org/markup-compatibility/2006" xmlns:p159="http://schemas.microsoft.com/office/powerpoint/2015/09/main">
+    <mc:Choice Requires="p159">
       <p:transition xmlns:p14="http://schemas.microsoft.com/office/powerpoint/2010/main" spd="slow" p14:dur="2000">
         <p159:morph option="byObject"/>
       </p:transition>
     </mc:Choice>
-    <mc:Fallback>
+    <mc:Fallback xmlns="">
       <p:transition spd="slow">
         <p:fade/>
       </p:transition>
@@ -12741,13 +12791,13 @@
   <p:clrMapOvr>
     <a:masterClrMapping/>
   </p:clrMapOvr>
-  <mc:AlternateContent xmlns:mc="http://schemas.openxmlformats.org/markup-compatibility/2006">
-    <mc:Choice xmlns:p14="http://schemas.microsoft.com/office/powerpoint/2010/main" Requires="p14">
+  <mc:AlternateContent xmlns:mc="http://schemas.openxmlformats.org/markup-compatibility/2006" xmlns:p14="http://schemas.microsoft.com/office/powerpoint/2010/main">
+    <mc:Choice Requires="p14">
       <p:transition spd="slow" p14:dur="800">
         <p:circle/>
       </p:transition>
     </mc:Choice>
-    <mc:Fallback>
+    <mc:Fallback xmlns="">
       <p:transition spd="slow">
         <p:circle/>
       </p:transition>
@@ -13682,13 +13732,13 @@
   <p:clrMapOvr>
     <a:masterClrMapping/>
   </p:clrMapOvr>
-  <mc:AlternateContent xmlns:mc="http://schemas.openxmlformats.org/markup-compatibility/2006">
-    <mc:Choice xmlns:p14="http://schemas.microsoft.com/office/powerpoint/2010/main" Requires="p14">
+  <mc:AlternateContent xmlns:mc="http://schemas.openxmlformats.org/markup-compatibility/2006" xmlns:p14="http://schemas.microsoft.com/office/powerpoint/2010/main">
+    <mc:Choice Requires="p14">
       <p:transition spd="slow" p14:dur="800">
         <p:circle/>
       </p:transition>
     </mc:Choice>
-    <mc:Fallback>
+    <mc:Fallback xmlns="">
       <p:transition spd="slow">
         <p:circle/>
       </p:transition>
@@ -14919,13 +14969,13 @@
   <p:clrMapOvr>
     <a:masterClrMapping/>
   </p:clrMapOvr>
-  <mc:AlternateContent xmlns:mc="http://schemas.openxmlformats.org/markup-compatibility/2006">
-    <mc:Choice xmlns:p159="http://schemas.microsoft.com/office/powerpoint/2015/09/main" Requires="p159">
+  <mc:AlternateContent xmlns:mc="http://schemas.openxmlformats.org/markup-compatibility/2006" xmlns:p159="http://schemas.microsoft.com/office/powerpoint/2015/09/main">
+    <mc:Choice Requires="p159">
       <p:transition xmlns:p14="http://schemas.microsoft.com/office/powerpoint/2010/main" spd="slow" p14:dur="2000">
         <p159:morph option="byObject"/>
       </p:transition>
     </mc:Choice>
-    <mc:Fallback>
+    <mc:Fallback xmlns="">
       <p:transition spd="slow">
         <p:fade/>
       </p:transition>

</xml_diff>